<commit_message>
Add day 2 powerpoint
</commit_message>
<xml_diff>
--- a/docs/MathFestLockMinicourse-Day2.pptx
+++ b/docs/MathFestLockMinicourse-Day2.pptx
@@ -15314,7 +15314,7 @@
         </p:nvSpPr>
         <p:spPr>
           <a:xfrm>
-            <a:off x="733778" y="2226796"/>
+            <a:off x="685800" y="2198574"/>
             <a:ext cx="8074152" cy="1077218"/>
           </a:xfrm>
           <a:prstGeom prst="rect">
@@ -15451,7 +15451,7 @@
           <p:cNvPr id="5" name="Picture 4">
             <a:extLst>
               <a:ext uri="{FF2B5EF4-FFF2-40B4-BE49-F238E27FC236}">
-                <a16:creationId xmlns:a16="http://schemas.microsoft.com/office/drawing/2014/main" id="{BE4946AC-307D-2492-0D25-6DA027E8739E}"/>
+                <a16:creationId xmlns:a16="http://schemas.microsoft.com/office/drawing/2014/main" id="{2F86A03C-A157-228E-2D89-71965440F250}"/>
               </a:ext>
             </a:extLst>
           </p:cNvPr>
@@ -15468,8 +15468,8 @@
         </p:blipFill>
         <p:spPr>
           <a:xfrm>
-            <a:off x="5334000" y="3443111"/>
-            <a:ext cx="2238687" cy="2124371"/>
+            <a:off x="5657704" y="3502072"/>
+            <a:ext cx="2095792" cy="2048161"/>
           </a:xfrm>
           <a:prstGeom prst="rect">
             <a:avLst/>
@@ -15481,7 +15481,7 @@
           <p:cNvPr id="7" name="TextBox 6">
             <a:extLst>
               <a:ext uri="{FF2B5EF4-FFF2-40B4-BE49-F238E27FC236}">
-                <a16:creationId xmlns:a16="http://schemas.microsoft.com/office/drawing/2014/main" id="{9CEDAED7-4823-67CB-83B2-1E28C4EEB57C}"/>
+                <a16:creationId xmlns:a16="http://schemas.microsoft.com/office/drawing/2014/main" id="{0BFA1B99-F70D-65D9-5348-22ABFA9E0ACA}"/>
               </a:ext>
             </a:extLst>
           </p:cNvPr>
@@ -15490,8 +15490,8 @@
         </p:nvSpPr>
         <p:spPr>
           <a:xfrm>
-            <a:off x="2740152" y="3973689"/>
-            <a:ext cx="3657600" cy="584775"/>
+            <a:off x="3389376" y="4060622"/>
+            <a:ext cx="2667000" cy="584775"/>
           </a:xfrm>
           <a:prstGeom prst="rect">
             <a:avLst/>

</xml_diff>